<commit_message>
Reframe leadership feedback in Wave 1 deck as structural, not personal
Co-Authored-By: Claude Opus 5.5 <noreply@anthropic.com>
Claude-Session: https://claude.ai/code/session_01EfuNgCYWvTH1bjq67Fx8My
</commit_message>
<xml_diff>
--- a/Fraser_Street_Medical_Wave1_Summary.pptx
+++ b/Fraser_Street_Medical_Wave1_Summary.pptx
@@ -115,13 +115,13 @@
   <p:extLst>
     <p:ext uri="{521415D9-36F7-43E2-AB2F-B90AF26B5E84}">
       <p14:sectionLst xmlns:p14="http://schemas.microsoft.com/office/powerpoint/2010/main">
-        <p14:section name="Introduction" id="{58253690-0c2a-beea-a789-46e7955c1071}">
+        <p14:section name="Introduction" id="{7d47b885-e74d-25dc-35b3-ce69d69e1490}">
           <p14:sldIdLst>
             <p14:sldId id="256"/>
             <p14:sldId id="257"/>
           </p14:sldIdLst>
         </p14:section>
-        <p14:section name="Findings" id="{8027f2da-a72f-881f-7fc4-fbde205fbfa1}">
+        <p14:section name="Findings" id="{e1a1c06d-78a1-6717-cff4-2d2d26451bee}">
           <p14:sldIdLst>
             <p14:sldId id="258"/>
             <p14:sldId id="259"/>
@@ -129,7 +129,7 @@
             <p14:sldId id="261"/>
           </p14:sldIdLst>
         </p14:section>
-        <p14:section name="Discussion" id="{9d0b4b53-c710-73b9-23b0-bf12b37723e2}">
+        <p14:section name="Discussion" id="{6eb37371-14d1-1e78-5414-22cfa55676fb}">
           <p14:sldIdLst>
             <p14:sldId id="262"/>
             <p14:sldId id="263"/>
@@ -3150,7 +3150,7 @@
                   <a:schemeClr val="accent4"/>
                 </a:solidFill>
               </a:rPr>
-              <a:t>Deep community roots, real innovation — and growing fragility</a:t>
+              <a:t>Deep community roots, real innovation — and a model that now needs support to sustain</a:t>
             </a:r>
             <a:endParaRPr lang="en-US" sz="1600" dirty="0"/>
           </a:p>
@@ -3573,7 +3573,7 @@
                   <a:schemeClr val="tx1"/>
                 </a:solidFill>
               </a:rPr>
-              <a:t>Systemic: team-based care is an unfunded, unrecognized mandate. Innovation without infrastructure is creating fragility in leadership, MOA confidence, and staff well-being.</a:t>
+              <a:t>Systemic: team-based care is an unfunded, unrecognized mandate. Innovation without infrastructure places growing strain on coordination, day-to-day workflows, and staff well-being.</a:t>
             </a:r>
             <a:endParaRPr lang="en-US" sz="1500" dirty="0"/>
           </a:p>
@@ -5678,7 +5678,7 @@
                           <a:ea typeface="Calibri" pitchFamily="34" charset="-122"/>
                           <a:cs typeface="Calibri" pitchFamily="34" charset="-120"/>
                         </a:rPr>
-                        <a:t>The Medical Director carries the full burden of building and sustaining the team model with no government recognition or compensation.</a:t>
+                        <a:t>The Medical Director has carried the work of building and sustaining the team model largely alone, with no government recognition or compensation.</a:t>
                       </a:r>
                       <a:endParaRPr lang="en-US" sz="1400" dirty="0">
                         <a:latin typeface="Calibri" charset="0"/>
@@ -5724,7 +5724,7 @@
                           <a:ea typeface="Calibri" pitchFamily="34" charset="-122"/>
                           <a:cs typeface="Calibri" pitchFamily="34" charset="-120"/>
                         </a:rPr>
-                        <a:t>Leadership Inconsistency</a:t>
+                        <a:t>Communication &amp; Coordination Load</a:t>
                       </a:r>
                       <a:endParaRPr lang="en-US" sz="1400" dirty="0">
                         <a:latin typeface="Calibri" charset="0"/>
@@ -5768,7 +5768,7 @@
                           <a:ea typeface="Calibri" pitchFamily="34" charset="-122"/>
                           <a:cs typeface="Calibri" pitchFamily="34" charset="-120"/>
                         </a:rPr>
-                        <a:t>Inconsistent policy enforcement erodes MOA confidence; the RN informally fills the management gap, creating unclear role boundaries.</a:t>
+                        <a:t>With no dedicated manager role, policy and workflow updates can reach staff unevenly; the RN has informally stepped in, and role boundaries are still settling.</a:t>
                       </a:r>
                       <a:endParaRPr lang="en-US" sz="1400" dirty="0">
                         <a:latin typeface="Calibri" charset="0"/>
@@ -6461,7 +6461,7 @@
       </p:sp>
       <p:sp>
         <p:nvSpPr>
-          <p:cNvPr id="9" name="Consistency &amp; confidence card"/>
+          <p:cNvPr id="9" name="Shared workflows card"/>
           <p:cNvSpPr/>
           <p:nvPr/>
         </p:nvSpPr>
@@ -6483,7 +6483,7 @@
       </p:sp>
       <p:sp>
         <p:nvSpPr>
-          <p:cNvPr id="10" name="Consistency &amp; confidence number circle"/>
+          <p:cNvPr id="10" name="Shared workflows number circle"/>
           <p:cNvSpPr/>
           <p:nvPr/>
         </p:nvSpPr>
@@ -6570,7 +6570,7 @@
                   <a:schemeClr val="tx2"/>
                 </a:solidFill>
               </a:rPr>
-              <a:t>Consistency &amp; confidence</a:t>
+              <a:t>Shared workflows</a:t>
             </a:r>
             <a:endParaRPr lang="en-US" sz="1800" dirty="0"/>
           </a:p>
@@ -6606,7 +6606,7 @@
                   <a:schemeClr val="tx1"/>
                 </a:solidFill>
               </a:rPr>
-              <a:t>What structures or supports would help improve leadership consistency and rebuild MOA confidence in clinic policies and workflows?</a:t>
+              <a:t>What structures (e.g., a point person, written workflows, team huddles) would help updates reach everyone consistently and give MOAs a clear place to raise questions?</a:t>
             </a:r>
             <a:endParaRPr lang="en-US" sz="1400" dirty="0"/>
           </a:p>

</xml_diff>

<commit_message>
Clarify management wording on pressures slide
Co-Authored-By: Claude Opus 5.5 <noreply@anthropic.com>
Claude-Session: https://claude.ai/code/session_01EfuNgCYWvTH1bjq67Fx8My
</commit_message>
<xml_diff>
--- a/Fraser_Street_Medical_Wave1_Summary.pptx
+++ b/Fraser_Street_Medical_Wave1_Summary.pptx
@@ -115,13 +115,13 @@
   <p:extLst>
     <p:ext uri="{521415D9-36F7-43E2-AB2F-B90AF26B5E84}">
       <p14:sectionLst xmlns:p14="http://schemas.microsoft.com/office/powerpoint/2010/main">
-        <p14:section name="Introduction" id="{7d47b885-e74d-25dc-35b3-ce69d69e1490}">
+        <p14:section name="Introduction" id="{77268d83-e4f1-8800-c791-26c7528cea8e}">
           <p14:sldIdLst>
             <p14:sldId id="256"/>
             <p14:sldId id="257"/>
           </p14:sldIdLst>
         </p14:section>
-        <p14:section name="Findings" id="{e1a1c06d-78a1-6717-cff4-2d2d26451bee}">
+        <p14:section name="Findings" id="{0312f30c-ea53-7bb6-8418-559bfc520022}">
           <p14:sldIdLst>
             <p14:sldId id="258"/>
             <p14:sldId id="259"/>
@@ -129,7 +129,7 @@
             <p14:sldId id="261"/>
           </p14:sldIdLst>
         </p14:section>
-        <p14:section name="Discussion" id="{6eb37371-14d1-1e78-5414-22cfa55676fb}">
+        <p14:section name="Discussion" id="{39360270-8e63-801c-032b-d20b6b9cead4}">
           <p14:sldIdLst>
             <p14:sldId id="262"/>
             <p14:sldId id="263"/>
@@ -5768,7 +5768,7 @@
                           <a:ea typeface="Calibri" pitchFamily="34" charset="-122"/>
                           <a:cs typeface="Calibri" pitchFamily="34" charset="-120"/>
                         </a:rPr>
-                        <a:t>With no dedicated manager role, policy and workflow updates can reach staff unevenly; the RN has informally stepped in, and role boundaries are still settling.</a:t>
+                        <a:t>With management tasks spread informally across the team, policy and workflow updates can reach staff unevenly; the RN has informally stepped in, and role boundaries are still settling.</a:t>
                       </a:r>
                       <a:endParaRPr lang="en-US" sz="1400" dirty="0">
                         <a:latin typeface="Calibri" charset="0"/>

</xml_diff>